<commit_message>
feat(brand): official Otula logo in the app and the pitch deck
- Brand: mark (four warm petals, mother & child) + wordmark from Otula-logo-HD.svg;
  wordmark colour is a token (logo brown by day, light beige at night)
- favicon.svg, PWA icons (192/512/maskable) and apple-touch-icon generated from the mark
  (the manifest pointed at icon files that did not exist)
- logo shown once on welcome/login/register (public header already has it), real logo
  in the visit report header, duplicate 'otula' text removed from the public circle page
- pitch: logo lockup on title, mark in footers and closing, logo watermark on dark slides;
  screenshots retaken with the new logo, Night Shift shot pinned to 03:12
- docs/design/otula-logo.svg: source logo

Co-Authored-By: Claude Opus 5.5 <noreply@anthropic.com>
</commit_message>
<xml_diff>
--- a/pitch/otula-pitch.pptx
+++ b/pitch/otula-pitch.pptx
@@ -116,40 +116,40 @@
   <p:extLst>
     <p:ext uri="{521415D9-36F7-43E2-AB2F-B90AF26B5E84}">
       <p14:sectionLst xmlns:p14="http://schemas.microsoft.com/office/powerpoint/2010/main">
-        <p14:section name="Opening" id="{5b24eaf3-07c4-3d08-6115-516da91a402a}">
+        <p14:section name="Opening" id="{1e4866ad-bd78-d26f-cedb-ef891c30fd47}">
           <p14:sldIdLst>
             <p14:sldId id="256"/>
           </p14:sldIdLst>
         </p14:section>
-        <p14:section name="Problem" id="{6ffbcfd2-dcb7-1ee5-eb36-94b46ccb4509}">
+        <p14:section name="Problem" id="{524d5b9f-f115-2cbd-3d09-78c4f6d63c4b}">
           <p14:sldIdLst>
             <p14:sldId id="257"/>
             <p14:sldId id="258"/>
           </p14:sldIdLst>
         </p14:section>
-        <p14:section name="Solution" id="{b09feae0-2e91-799f-5b19-5ac5bd61cff2}">
+        <p14:section name="Solution" id="{5cb637fa-04dd-d69f-da9c-fe4be866b1a8}">
           <p14:sldIdLst>
             <p14:sldId id="259"/>
           </p14:sldIdLst>
         </p14:section>
-        <p14:section name="Innovation" id="{3d041716-c0e1-4fc8-907b-aed595591546}">
+        <p14:section name="Innovation" id="{4b5438e0-162b-6b85-9af3-a38cd42da017}">
           <p14:sldIdLst>
             <p14:sldId id="260"/>
             <p14:sldId id="261"/>
             <p14:sldId id="262"/>
           </p14:sldIdLst>
         </p14:section>
-        <p14:section name="Safety" id="{ed26f034-c387-f5fa-cc86-fbbb90ee5b45}">
+        <p14:section name="Safety" id="{966ce053-f6f0-acb7-774f-7b8ac6dd33aa}">
           <p14:sldIdLst>
             <p14:sldId id="263"/>
           </p14:sldIdLst>
         </p14:section>
-        <p14:section name="Build" id="{732875be-7eb9-c773-3e31-598dd76d4056}">
+        <p14:section name="Build" id="{dabd2bc8-f0e7-ecdb-c62d-55657316814f}">
           <p14:sldIdLst>
             <p14:sldId id="264"/>
           </p14:sldIdLst>
         </p14:section>
-        <p14:section name="Close" id="{10c97aac-95cf-297a-3caf-3fd10efbb91c}">
+        <p14:section name="Close" id="{c7ec1cc8-acd7-b72a-1f9c-5b8b91a886f3}">
           <p14:sldIdLst>
             <p14:sldId id="265"/>
           </p14:sldIdLst>
@@ -1448,7 +1448,7 @@
       </p:grpSpPr>
       <p:pic>
         <p:nvPicPr>
-          <p:cNvPr id="2" name="Image 0" descr="assets/petals-ghost.png">    </p:cNvPr>
+          <p:cNvPr id="2" name="Image 0" descr="assets/logo-ghost.png">    </p:cNvPr>
           <p:cNvPicPr>
             <a:picLocks noChangeAspect="1"/>
           </p:cNvPicPr>
@@ -1462,8 +1462,8 @@
         </p:blipFill>
         <p:spPr>
           <a:xfrm>
-            <a:off x="6766560" y="-1097280"/>
-            <a:ext cx="6949440" cy="6949440"/>
+            <a:off x="7223760" y="-822960"/>
+            <a:ext cx="6035040" cy="6844937"/>
           </a:xfrm>
           <a:prstGeom prst="rect">
             <a:avLst/>
@@ -1504,7 +1504,7 @@
       </p:grpSpPr>
       <p:pic>
         <p:nvPicPr>
-          <p:cNvPr id="2" name="Image 0" descr="assets/petals-forest.png">    </p:cNvPr>
+          <p:cNvPr id="2" name="Image 0" descr="assets/logo-mark.png">    </p:cNvPr>
           <p:cNvPicPr>
             <a:picLocks noChangeAspect="1"/>
           </p:cNvPicPr>
@@ -1518,8 +1518,8 @@
         </p:blipFill>
         <p:spPr>
           <a:xfrm>
-            <a:off x="11387023" y="6382512"/>
-            <a:ext cx="256032" cy="256032"/>
+            <a:off x="11387023" y="6345936"/>
+            <a:ext cx="256032" cy="290391"/>
           </a:xfrm>
           <a:prstGeom prst="rect">
             <a:avLst/>
@@ -1692,7 +1692,7 @@
       </p:grpSpPr>
       <p:pic>
         <p:nvPicPr>
-          <p:cNvPr id="2" name="Image 0" descr="assets/petals-amber.png">    </p:cNvPr>
+          <p:cNvPr id="2" name="Image 0" descr="assets/logo-mark.png">    </p:cNvPr>
           <p:cNvPicPr>
             <a:picLocks noChangeAspect="1"/>
           </p:cNvPicPr>
@@ -1706,8 +1706,8 @@
         </p:blipFill>
         <p:spPr>
           <a:xfrm>
-            <a:off x="11387023" y="6382512"/>
-            <a:ext cx="256032" cy="256032"/>
+            <a:off x="11387023" y="6345936"/>
+            <a:ext cx="256032" cy="290391"/>
           </a:xfrm>
           <a:prstGeom prst="rect">
             <a:avLst/>
@@ -2201,7 +2201,7 @@
       </p:grpSpPr>
       <p:pic>
         <p:nvPicPr>
-          <p:cNvPr id="2" name="logo mark" descr="assets/petals-cream.png">    </p:cNvPr>
+          <p:cNvPr id="2" name="Otula logo" descr="assets/logo-lockup-cream.png">    </p:cNvPr>
           <p:cNvPicPr>
             <a:picLocks noChangeAspect="1"/>
           </p:cNvPicPr>
@@ -2215,8 +2215,8 @@
         </p:blipFill>
         <p:spPr>
           <a:xfrm>
-            <a:off x="548640" y="640080"/>
-            <a:ext cx="502920" cy="502920"/>
+            <a:off x="548640" y="502920"/>
+            <a:ext cx="1775489" cy="777240"/>
           </a:xfrm>
           <a:prstGeom prst="rect">
             <a:avLst/>
@@ -2231,57 +2231,38 @@
         </p:nvSpPr>
         <p:spPr>
           <a:xfrm>
-            <a:off x="1188720" y="621792"/>
-            <a:ext cx="2743200" cy="548640"/>
-          </a:xfrm>
-          <a:prstGeom prst="rect">
-            <a:avLst/>
-          </a:prstGeom>
-          <a:noFill/>
-          <a:ln/>
-        </p:spPr>
-        <p:txBody>
-          <a:bodyPr wrap="square" lIns="0" tIns="0" rIns="0" bIns="0" rtlCol="0" anchor="ctr"/>
-          <a:lstStyle/>
-          <a:p>
-            <a:pPr indent="0" marL="0">
-              <a:buNone/>
-            </a:pPr>
-            <a:r>
-              <a:rPr lang="en-US" sz="3000" dirty="0">
-                <a:solidFill>
-                  <a:srgbClr val="F8F5EF"/>
+            <a:off x="548640" y="1828800"/>
+            <a:ext cx="6583680" cy="2011680"/>
+          </a:xfrm>
+          <a:prstGeom prst="rect">
+            <a:avLst/>
+          </a:prstGeom>
+          <a:noFill/>
+          <a:ln/>
+        </p:spPr>
+        <p:txBody>
+          <a:bodyPr wrap="square" lIns="0" tIns="0" rIns="0" bIns="0" rtlCol="0" anchor="t"/>
+          <a:lstStyle/>
+          <a:p>
+            <a:pPr indent="0" marL="0">
+              <a:lnSpc>
+                <a:spcPct val="100000"/>
+              </a:lnSpc>
+              <a:buNone/>
+            </a:pPr>
+            <a:r>
+              <a:rPr lang="en-US" sz="4800" dirty="0">
+                <a:solidFill>
+                  <a:srgbClr val="FFFDF9"/>
                 </a:solidFill>
                 <a:latin typeface="Georgia" pitchFamily="34" charset="0"/>
                 <a:ea typeface="Georgia" pitchFamily="34" charset="-122"/>
                 <a:cs typeface="Georgia" pitchFamily="34" charset="-120"/>
               </a:rPr>
-              <a:t>otula</a:t>
-            </a:r>
-            <a:endParaRPr lang="en-US" sz="3000" dirty="0"/>
-          </a:p>
-        </p:txBody>
-      </p:sp>
-      <p:sp>
-        <p:nvSpPr>
-          <p:cNvPr id="4" name="Text 1"/>
-          <p:cNvSpPr txBox="1"/>
-          <p:nvPr/>
-        </p:nvSpPr>
-        <p:spPr>
-          <a:xfrm>
-            <a:off x="548640" y="1828800"/>
-            <a:ext cx="6583680" cy="2011680"/>
-          </a:xfrm>
-          <a:prstGeom prst="rect">
-            <a:avLst/>
-          </a:prstGeom>
-          <a:noFill/>
-          <a:ln/>
-        </p:spPr>
-        <p:txBody>
-          <a:bodyPr wrap="square" lIns="0" tIns="0" rIns="0" bIns="0" rtlCol="0" anchor="t"/>
-          <a:lstStyle/>
+              <a:t>Care for the mother,</a:t>
+            </a:r>
+            <a:endParaRPr lang="en-US" sz="4800" dirty="0"/>
+          </a:p>
           <a:p>
             <a:pPr indent="0" marL="0">
               <a:lnSpc>
@@ -2298,35 +2279,15 @@
                 <a:ea typeface="Georgia" pitchFamily="34" charset="-122"/>
                 <a:cs typeface="Georgia" pitchFamily="34" charset="-120"/>
               </a:rPr>
-              <a:t>Care for the mother,</a:t>
+              <a:t>not just the baby.</a:t>
             </a:r>
             <a:endParaRPr lang="en-US" sz="4800" dirty="0"/>
           </a:p>
-          <a:p>
-            <a:pPr indent="0" marL="0">
-              <a:lnSpc>
-                <a:spcPct val="100000"/>
-              </a:lnSpc>
-              <a:buNone/>
-            </a:pPr>
-            <a:r>
-              <a:rPr lang="en-US" sz="4800" dirty="0">
-                <a:solidFill>
-                  <a:srgbClr val="FFFDF9"/>
-                </a:solidFill>
-                <a:latin typeface="Georgia" pitchFamily="34" charset="0"/>
-                <a:ea typeface="Georgia" pitchFamily="34" charset="-122"/>
-                <a:cs typeface="Georgia" pitchFamily="34" charset="-120"/>
-              </a:rPr>
-              <a:t>not just the baby.</a:t>
-            </a:r>
-            <a:endParaRPr lang="en-US" sz="4800" dirty="0"/>
-          </a:p>
-        </p:txBody>
-      </p:sp>
-      <p:sp>
-        <p:nvSpPr>
-          <p:cNvPr id="5" name="Text 2"/>
+        </p:txBody>
+      </p:sp>
+      <p:sp>
+        <p:nvSpPr>
+          <p:cNvPr id="4" name="Text 1"/>
           <p:cNvSpPr txBox="1"/>
           <p:nvPr/>
         </p:nvSpPr>
@@ -2365,7 +2326,7 @@
       </p:sp>
       <p:sp>
         <p:nvSpPr>
-          <p:cNvPr id="6" name="event pill"/>
+          <p:cNvPr id="5" name="event pill"/>
           <p:cNvSpPr/>
           <p:nvPr/>
         </p:nvSpPr>
@@ -2392,7 +2353,7 @@
       </p:sp>
       <p:sp>
         <p:nvSpPr>
-          <p:cNvPr id="7" name="Text 4"/>
+          <p:cNvPr id="6" name="Text 3"/>
           <p:cNvSpPr txBox="1"/>
           <p:nvPr/>
         </p:nvSpPr>
@@ -2431,7 +2392,7 @@
       </p:sp>
       <p:pic>
         <p:nvPicPr>
-          <p:cNvPr id="8" name="phone mobile-today" descr="assets/mobile-today.png">    </p:cNvPr>
+          <p:cNvPr id="7" name="phone mobile-today" descr="assets/mobile-today.png">    </p:cNvPr>
           <p:cNvPicPr>
             <a:picLocks noChangeAspect="1"/>
           </p:cNvPicPr>
@@ -3184,7 +3145,7 @@
       </p:sp>
       <p:pic>
         <p:nvPicPr>
-          <p:cNvPr id="19" name="logo mark" descr="assets/petals-cream.png">    </p:cNvPr>
+          <p:cNvPr id="19" name="Otula logo mark" descr="assets/logo-mark.png">    </p:cNvPr>
           <p:cNvPicPr>
             <a:picLocks noChangeAspect="1"/>
           </p:cNvPicPr>
@@ -3198,8 +3159,8 @@
         </p:blipFill>
         <p:spPr>
           <a:xfrm>
-            <a:off x="548640" y="5806440"/>
-            <a:ext cx="384048" cy="384048"/>
+            <a:off x="548640" y="5760720"/>
+            <a:ext cx="370856" cy="420624"/>
           </a:xfrm>
           <a:prstGeom prst="rect">
             <a:avLst/>
@@ -3239,7 +3200,7 @@
                 <a:ea typeface="Georgia" pitchFamily="34" charset="-122"/>
                 <a:cs typeface="Georgia" pitchFamily="34" charset="-120"/>
               </a:rPr>
-              <a:t>otula — care for the mother, not just the baby.</a:t>
+              <a:t>Otula — care for the mother, not just the baby.</a:t>
             </a:r>
             <a:endParaRPr lang="en-US" sz="1600" dirty="0"/>
           </a:p>

</xml_diff>